<commit_message>
4th sem and 5th sem last updtae
</commit_message>
<xml_diff>
--- a/5th sem/ComputerNetwork/Chapter new 3.pptx
+++ b/5th sem/ComputerNetwork/Chapter new 3.pptx
@@ -85,7 +85,7 @@
         <p:spPr>
           <a:xfrm>
             <a:off x="838080" y="365040"/>
-            <a:ext cx="10514880" cy="1324800"/>
+            <a:ext cx="10514520" cy="1324440"/>
           </a:xfrm>
           <a:prstGeom prst="rect">
             <a:avLst/>
@@ -125,7 +125,7 @@
         <p:spPr>
           <a:xfrm>
             <a:off x="838080" y="1825560"/>
-            <a:ext cx="10514880" cy="4350600"/>
+            <a:ext cx="10514520" cy="4350240"/>
           </a:xfrm>
           <a:prstGeom prst="rect">
             <a:avLst/>
@@ -189,7 +189,7 @@
         <p:txBody>
           <a:bodyPr/>
           <a:p>
-            <a:fld id="{CFFF818F-9389-4AA7-ABFA-D43AC59C44D7}" type="slidenum">
+            <a:fld id="{3D666C9E-0D56-4F6A-9694-980FD417A5A6}" type="slidenum">
               <a:t>&lt;#&gt;</a:t>
             </a:fld>
           </a:p>
@@ -251,7 +251,7 @@
         <p:spPr>
           <a:xfrm>
             <a:off x="838080" y="365040"/>
-            <a:ext cx="10514880" cy="1324800"/>
+            <a:ext cx="10514520" cy="1324440"/>
           </a:xfrm>
           <a:prstGeom prst="rect">
             <a:avLst/>
@@ -291,7 +291,7 @@
         <p:spPr>
           <a:xfrm>
             <a:off x="838080" y="1825560"/>
-            <a:ext cx="10514880" cy="4350600"/>
+            <a:ext cx="10514520" cy="4350240"/>
           </a:xfrm>
           <a:prstGeom prst="rect">
             <a:avLst/>
@@ -355,7 +355,7 @@
         <p:txBody>
           <a:bodyPr/>
           <a:p>
-            <a:fld id="{EB70EB45-BD23-4467-8714-8CC0D0BDFA22}" type="slidenum">
+            <a:fld id="{7285CE24-A584-4B76-AB29-554C148D9D01}" type="slidenum">
               <a:t>&lt;#&gt;</a:t>
             </a:fld>
           </a:p>
@@ -417,7 +417,7 @@
         <p:spPr>
           <a:xfrm>
             <a:off x="838080" y="365040"/>
-            <a:ext cx="10514880" cy="1324800"/>
+            <a:ext cx="10514520" cy="1324440"/>
           </a:xfrm>
           <a:prstGeom prst="rect">
             <a:avLst/>
@@ -457,7 +457,7 @@
         <p:spPr>
           <a:xfrm>
             <a:off x="838080" y="1825560"/>
-            <a:ext cx="10514880" cy="4350600"/>
+            <a:ext cx="10514520" cy="4350240"/>
           </a:xfrm>
           <a:prstGeom prst="rect">
             <a:avLst/>
@@ -521,7 +521,7 @@
         <p:txBody>
           <a:bodyPr/>
           <a:p>
-            <a:fld id="{05A6172B-C785-434C-8AFA-2C49922296C1}" type="slidenum">
+            <a:fld id="{13E4D988-8082-46BC-8ED7-BCC6F870DD13}" type="slidenum">
               <a:t>&lt;#&gt;</a:t>
             </a:fld>
           </a:p>
@@ -583,7 +583,7 @@
         <p:spPr>
           <a:xfrm>
             <a:off x="838080" y="365040"/>
-            <a:ext cx="10514880" cy="1324800"/>
+            <a:ext cx="10514520" cy="1324440"/>
           </a:xfrm>
           <a:prstGeom prst="rect">
             <a:avLst/>
@@ -623,7 +623,7 @@
         <p:spPr>
           <a:xfrm>
             <a:off x="838080" y="1825560"/>
-            <a:ext cx="10514880" cy="4350600"/>
+            <a:ext cx="10514520" cy="4350240"/>
           </a:xfrm>
           <a:prstGeom prst="rect">
             <a:avLst/>
@@ -687,7 +687,7 @@
         <p:txBody>
           <a:bodyPr/>
           <a:p>
-            <a:fld id="{6B155A47-1180-4194-862E-70FC72BFF63E}" type="slidenum">
+            <a:fld id="{252BD5D0-94D8-4515-AEDF-F4A4CAAB188A}" type="slidenum">
               <a:t>&lt;#&gt;</a:t>
             </a:fld>
           </a:p>
@@ -749,7 +749,7 @@
         <p:spPr>
           <a:xfrm>
             <a:off x="838080" y="365040"/>
-            <a:ext cx="10514880" cy="1324800"/>
+            <a:ext cx="10514520" cy="1324440"/>
           </a:xfrm>
           <a:prstGeom prst="rect">
             <a:avLst/>
@@ -789,7 +789,7 @@
         <p:spPr>
           <a:xfrm>
             <a:off x="838080" y="1825560"/>
-            <a:ext cx="5131080" cy="4350600"/>
+            <a:ext cx="5131080" cy="4350240"/>
           </a:xfrm>
           <a:prstGeom prst="rect">
             <a:avLst/>
@@ -832,7 +832,7 @@
         <p:spPr>
           <a:xfrm>
             <a:off x="6226200" y="1825560"/>
-            <a:ext cx="5131080" cy="4350600"/>
+            <a:ext cx="5131080" cy="4350240"/>
           </a:xfrm>
           <a:prstGeom prst="rect">
             <a:avLst/>
@@ -896,7 +896,7 @@
         <p:txBody>
           <a:bodyPr/>
           <a:p>
-            <a:fld id="{DE39D2CF-C042-4E25-B8CC-9DCAA37C44AE}" type="slidenum">
+            <a:fld id="{F183F953-76AA-438A-8C23-528B67850A02}" type="slidenum">
               <a:t>&lt;#&gt;</a:t>
             </a:fld>
           </a:p>
@@ -958,7 +958,7 @@
         <p:spPr>
           <a:xfrm>
             <a:off x="838080" y="365040"/>
-            <a:ext cx="10514880" cy="1324800"/>
+            <a:ext cx="10514520" cy="1324440"/>
           </a:xfrm>
           <a:prstGeom prst="rect">
             <a:avLst/>
@@ -998,7 +998,7 @@
         <p:spPr>
           <a:xfrm>
             <a:off x="838080" y="1825560"/>
-            <a:ext cx="5131080" cy="4350600"/>
+            <a:ext cx="5131080" cy="4350240"/>
           </a:xfrm>
           <a:prstGeom prst="rect">
             <a:avLst/>
@@ -1041,7 +1041,7 @@
         <p:spPr>
           <a:xfrm>
             <a:off x="6226200" y="1825560"/>
-            <a:ext cx="5131080" cy="4350600"/>
+            <a:ext cx="5131080" cy="4350240"/>
           </a:xfrm>
           <a:prstGeom prst="rect">
             <a:avLst/>
@@ -1105,7 +1105,7 @@
         <p:txBody>
           <a:bodyPr/>
           <a:p>
-            <a:fld id="{357639F3-BF73-4E63-BDD8-5C5CD4FC7886}" type="slidenum">
+            <a:fld id="{ED741ECC-D908-4D40-8540-75770296344F}" type="slidenum">
               <a:t>&lt;#&gt;</a:t>
             </a:fld>
           </a:p>
@@ -1188,7 +1188,7 @@
         <p:txBody>
           <a:bodyPr/>
           <a:p>
-            <a:fld id="{E4CA80A7-3BAF-49A2-B519-EAF06A299E83}" type="slidenum">
+            <a:fld id="{C86239BE-8F22-4C26-8264-24BCA5BD0204}" type="slidenum">
               <a:t>&lt;#&gt;</a:t>
             </a:fld>
           </a:p>
@@ -1257,7 +1257,7 @@
         <p:spPr>
           <a:xfrm>
             <a:off x="838080" y="365040"/>
-            <a:ext cx="10514880" cy="1324800"/>
+            <a:ext cx="10514520" cy="1324440"/>
           </a:xfrm>
           <a:prstGeom prst="rect">
             <a:avLst/>
@@ -1306,7 +1306,7 @@
         <p:spPr>
           <a:xfrm>
             <a:off x="838080" y="1825560"/>
-            <a:ext cx="10514880" cy="4350600"/>
+            <a:ext cx="10514520" cy="4350240"/>
           </a:xfrm>
           <a:prstGeom prst="rect">
             <a:avLst/>
@@ -1531,7 +1531,7 @@
         <p:spPr>
           <a:xfrm>
             <a:off x="4038480" y="6356520"/>
-            <a:ext cx="4114080" cy="364320"/>
+            <a:ext cx="4113720" cy="363960"/>
           </a:xfrm>
           <a:prstGeom prst="rect">
             <a:avLst/>
@@ -1603,7 +1603,7 @@
         <p:spPr>
           <a:xfrm>
             <a:off x="8610480" y="6356520"/>
-            <a:ext cx="2742480" cy="364320"/>
+            <a:ext cx="2742120" cy="363960"/>
           </a:xfrm>
           <a:prstGeom prst="rect">
             <a:avLst/>
@@ -1646,7 +1646,7 @@
                 <a:tab algn="l" pos="0"/>
               </a:tabLst>
             </a:pPr>
-            <a:fld id="{44BD6B92-BCCD-4663-ABA2-A3C972183036}" type="slidenum">
+            <a:fld id="{E551C80D-BD8F-4EA0-984D-2341028F381E}" type="slidenum">
               <a:rPr b="0" lang="en-US" sz="1200" spc="-1" strike="noStrike">
                 <a:solidFill>
                   <a:schemeClr val="dk1">
@@ -1679,7 +1679,7 @@
         <p:spPr>
           <a:xfrm>
             <a:off x="838080" y="6356520"/>
-            <a:ext cx="2742480" cy="364320"/>
+            <a:ext cx="2742120" cy="363960"/>
           </a:xfrm>
           <a:prstGeom prst="rect">
             <a:avLst/>
@@ -1772,7 +1772,7 @@
         <p:spPr>
           <a:xfrm>
             <a:off x="838080" y="365040"/>
-            <a:ext cx="10514880" cy="1324800"/>
+            <a:ext cx="10514520" cy="1324440"/>
           </a:xfrm>
           <a:prstGeom prst="rect">
             <a:avLst/>
@@ -1821,7 +1821,7 @@
         <p:spPr>
           <a:xfrm>
             <a:off x="838080" y="1825560"/>
-            <a:ext cx="10514880" cy="4350600"/>
+            <a:ext cx="10514520" cy="4350240"/>
           </a:xfrm>
           <a:prstGeom prst="rect">
             <a:avLst/>
@@ -2046,7 +2046,7 @@
         <p:spPr>
           <a:xfrm>
             <a:off x="4038480" y="6356520"/>
-            <a:ext cx="4114080" cy="364320"/>
+            <a:ext cx="4113720" cy="363960"/>
           </a:xfrm>
           <a:prstGeom prst="rect">
             <a:avLst/>
@@ -2118,7 +2118,7 @@
         <p:spPr>
           <a:xfrm>
             <a:off x="8610480" y="6356520"/>
-            <a:ext cx="2742480" cy="364320"/>
+            <a:ext cx="2742120" cy="363960"/>
           </a:xfrm>
           <a:prstGeom prst="rect">
             <a:avLst/>
@@ -2161,7 +2161,7 @@
                 <a:tab algn="l" pos="0"/>
               </a:tabLst>
             </a:pPr>
-            <a:fld id="{EDDCBDC2-D535-4B8A-B890-696305B97123}" type="slidenum">
+            <a:fld id="{7035AA31-FCF1-42BB-8E96-70FA69F5B728}" type="slidenum">
               <a:rPr b="0" lang="en-US" sz="1200" spc="-1" strike="noStrike">
                 <a:solidFill>
                   <a:schemeClr val="dk1">
@@ -2194,7 +2194,7 @@
         <p:spPr>
           <a:xfrm>
             <a:off x="838080" y="6356520"/>
-            <a:ext cx="2742480" cy="364320"/>
+            <a:ext cx="2742120" cy="363960"/>
           </a:xfrm>
           <a:prstGeom prst="rect">
             <a:avLst/>
@@ -2287,7 +2287,7 @@
         <p:spPr>
           <a:xfrm>
             <a:off x="838080" y="365040"/>
-            <a:ext cx="10514880" cy="1324800"/>
+            <a:ext cx="10514520" cy="1324440"/>
           </a:xfrm>
           <a:prstGeom prst="rect">
             <a:avLst/>
@@ -2336,7 +2336,7 @@
         <p:spPr>
           <a:xfrm>
             <a:off x="838080" y="1825560"/>
-            <a:ext cx="10514880" cy="4350600"/>
+            <a:ext cx="10514520" cy="4350240"/>
           </a:xfrm>
           <a:prstGeom prst="rect">
             <a:avLst/>
@@ -2561,7 +2561,7 @@
         <p:spPr>
           <a:xfrm>
             <a:off x="4038480" y="6356520"/>
-            <a:ext cx="4114080" cy="364320"/>
+            <a:ext cx="4113720" cy="363960"/>
           </a:xfrm>
           <a:prstGeom prst="rect">
             <a:avLst/>
@@ -2633,7 +2633,7 @@
         <p:spPr>
           <a:xfrm>
             <a:off x="8610480" y="6356520"/>
-            <a:ext cx="2742480" cy="364320"/>
+            <a:ext cx="2742120" cy="363960"/>
           </a:xfrm>
           <a:prstGeom prst="rect">
             <a:avLst/>
@@ -2676,7 +2676,7 @@
                 <a:tab algn="l" pos="0"/>
               </a:tabLst>
             </a:pPr>
-            <a:fld id="{FF71064E-3584-4F60-A7D8-929AA196431E}" type="slidenum">
+            <a:fld id="{D4B8479E-9804-4122-8225-DE341C4D3C65}" type="slidenum">
               <a:rPr b="0" lang="en-US" sz="1200" spc="-1" strike="noStrike">
                 <a:solidFill>
                   <a:schemeClr val="dk1">
@@ -2709,7 +2709,7 @@
         <p:spPr>
           <a:xfrm>
             <a:off x="838080" y="6356520"/>
-            <a:ext cx="2742480" cy="364320"/>
+            <a:ext cx="2742120" cy="363960"/>
           </a:xfrm>
           <a:prstGeom prst="rect">
             <a:avLst/>
@@ -2802,7 +2802,7 @@
         <p:spPr>
           <a:xfrm>
             <a:off x="838080" y="365040"/>
-            <a:ext cx="10514880" cy="1324800"/>
+            <a:ext cx="10514520" cy="1324440"/>
           </a:xfrm>
           <a:prstGeom prst="rect">
             <a:avLst/>
@@ -2851,7 +2851,7 @@
         <p:spPr>
           <a:xfrm>
             <a:off x="838080" y="1825560"/>
-            <a:ext cx="10514880" cy="4350600"/>
+            <a:ext cx="10514520" cy="4350240"/>
           </a:xfrm>
           <a:prstGeom prst="rect">
             <a:avLst/>
@@ -3076,7 +3076,7 @@
         <p:spPr>
           <a:xfrm>
             <a:off x="4038480" y="6356520"/>
-            <a:ext cx="4114080" cy="364320"/>
+            <a:ext cx="4113720" cy="363960"/>
           </a:xfrm>
           <a:prstGeom prst="rect">
             <a:avLst/>
@@ -3148,7 +3148,7 @@
         <p:spPr>
           <a:xfrm>
             <a:off x="8610480" y="6356520"/>
-            <a:ext cx="2742480" cy="364320"/>
+            <a:ext cx="2742120" cy="363960"/>
           </a:xfrm>
           <a:prstGeom prst="rect">
             <a:avLst/>
@@ -3191,7 +3191,7 @@
                 <a:tab algn="l" pos="0"/>
               </a:tabLst>
             </a:pPr>
-            <a:fld id="{8070B9D8-0A76-428A-9D44-282CF50E8FE9}" type="slidenum">
+            <a:fld id="{48ED7016-332F-4126-9B3B-EF383467928B}" type="slidenum">
               <a:rPr b="0" lang="en-US" sz="1200" spc="-1" strike="noStrike">
                 <a:solidFill>
                   <a:schemeClr val="dk1">
@@ -3224,7 +3224,7 @@
         <p:spPr>
           <a:xfrm>
             <a:off x="838080" y="6356520"/>
-            <a:ext cx="2742480" cy="364320"/>
+            <a:ext cx="2742120" cy="363960"/>
           </a:xfrm>
           <a:prstGeom prst="rect">
             <a:avLst/>
@@ -3317,7 +3317,7 @@
         <p:spPr>
           <a:xfrm>
             <a:off x="838080" y="365040"/>
-            <a:ext cx="10514880" cy="1324800"/>
+            <a:ext cx="10514520" cy="1324440"/>
           </a:xfrm>
           <a:prstGeom prst="rect">
             <a:avLst/>
@@ -3366,7 +3366,7 @@
         <p:spPr>
           <a:xfrm>
             <a:off x="838080" y="1825560"/>
-            <a:ext cx="5130720" cy="4350600"/>
+            <a:ext cx="5130720" cy="4350240"/>
           </a:xfrm>
           <a:prstGeom prst="rect">
             <a:avLst/>
@@ -3591,7 +3591,7 @@
         <p:spPr>
           <a:xfrm>
             <a:off x="6226200" y="1825560"/>
-            <a:ext cx="5130720" cy="4350600"/>
+            <a:ext cx="5130720" cy="4350240"/>
           </a:xfrm>
           <a:prstGeom prst="rect">
             <a:avLst/>
@@ -3816,7 +3816,7 @@
         <p:spPr>
           <a:xfrm>
             <a:off x="4038480" y="6356520"/>
-            <a:ext cx="4114080" cy="364320"/>
+            <a:ext cx="4113720" cy="363960"/>
           </a:xfrm>
           <a:prstGeom prst="rect">
             <a:avLst/>
@@ -3888,7 +3888,7 @@
         <p:spPr>
           <a:xfrm>
             <a:off x="8610480" y="6356520"/>
-            <a:ext cx="2742480" cy="364320"/>
+            <a:ext cx="2742120" cy="363960"/>
           </a:xfrm>
           <a:prstGeom prst="rect">
             <a:avLst/>
@@ -3931,7 +3931,7 @@
                 <a:tab algn="l" pos="0"/>
               </a:tabLst>
             </a:pPr>
-            <a:fld id="{5351429F-B508-4469-AD77-E07FC608F332}" type="slidenum">
+            <a:fld id="{D373EBCB-8224-4128-844A-2A31BFC591FD}" type="slidenum">
               <a:rPr b="0" lang="en-US" sz="1200" spc="-1" strike="noStrike">
                 <a:solidFill>
                   <a:schemeClr val="dk1">
@@ -3964,7 +3964,7 @@
         <p:spPr>
           <a:xfrm>
             <a:off x="838080" y="6356520"/>
-            <a:ext cx="2742480" cy="364320"/>
+            <a:ext cx="2742120" cy="363960"/>
           </a:xfrm>
           <a:prstGeom prst="rect">
             <a:avLst/>
@@ -4057,7 +4057,7 @@
         <p:spPr>
           <a:xfrm>
             <a:off x="838080" y="365040"/>
-            <a:ext cx="10514880" cy="1324800"/>
+            <a:ext cx="10514520" cy="1324440"/>
           </a:xfrm>
           <a:prstGeom prst="rect">
             <a:avLst/>
@@ -4106,7 +4106,7 @@
         <p:spPr>
           <a:xfrm>
             <a:off x="838080" y="1825560"/>
-            <a:ext cx="5130720" cy="4350600"/>
+            <a:ext cx="5130720" cy="4350240"/>
           </a:xfrm>
           <a:prstGeom prst="rect">
             <a:avLst/>
@@ -4331,7 +4331,7 @@
         <p:spPr>
           <a:xfrm>
             <a:off x="6226200" y="1825560"/>
-            <a:ext cx="5130720" cy="4350600"/>
+            <a:ext cx="5130720" cy="4350240"/>
           </a:xfrm>
           <a:prstGeom prst="rect">
             <a:avLst/>
@@ -4556,7 +4556,7 @@
         <p:spPr>
           <a:xfrm>
             <a:off x="4038480" y="6356520"/>
-            <a:ext cx="4114080" cy="364320"/>
+            <a:ext cx="4113720" cy="363960"/>
           </a:xfrm>
           <a:prstGeom prst="rect">
             <a:avLst/>
@@ -4628,7 +4628,7 @@
         <p:spPr>
           <a:xfrm>
             <a:off x="8610480" y="6356520"/>
-            <a:ext cx="2742480" cy="364320"/>
+            <a:ext cx="2742120" cy="363960"/>
           </a:xfrm>
           <a:prstGeom prst="rect">
             <a:avLst/>
@@ -4671,7 +4671,7 @@
                 <a:tab algn="l" pos="0"/>
               </a:tabLst>
             </a:pPr>
-            <a:fld id="{425A31AE-DA1E-4753-9EF1-750F14BC3705}" type="slidenum">
+            <a:fld id="{8C8EFF42-6580-4D46-8E92-034BAB4B8689}" type="slidenum">
               <a:rPr b="0" lang="en-US" sz="1200" spc="-1" strike="noStrike">
                 <a:solidFill>
                   <a:schemeClr val="dk1">
@@ -4704,7 +4704,7 @@
         <p:spPr>
           <a:xfrm>
             <a:off x="838080" y="6356520"/>
-            <a:ext cx="2742480" cy="364320"/>
+            <a:ext cx="2742120" cy="363960"/>
           </a:xfrm>
           <a:prstGeom prst="rect">
             <a:avLst/>
@@ -4797,7 +4797,7 @@
         <p:spPr>
           <a:xfrm>
             <a:off x="4038480" y="6356520"/>
-            <a:ext cx="4114080" cy="364320"/>
+            <a:ext cx="4113720" cy="363960"/>
           </a:xfrm>
           <a:prstGeom prst="rect">
             <a:avLst/>
@@ -4869,7 +4869,7 @@
         <p:spPr>
           <a:xfrm>
             <a:off x="8610480" y="6356520"/>
-            <a:ext cx="2742480" cy="364320"/>
+            <a:ext cx="2742120" cy="363960"/>
           </a:xfrm>
           <a:prstGeom prst="rect">
             <a:avLst/>
@@ -4912,7 +4912,7 @@
                 <a:tab algn="l" pos="0"/>
               </a:tabLst>
             </a:pPr>
-            <a:fld id="{62984ED0-80CC-494C-A004-B41B3BD49740}" type="slidenum">
+            <a:fld id="{C59413C8-2AC5-4764-AADB-936D0B60369F}" type="slidenum">
               <a:rPr b="0" lang="en-US" sz="1200" spc="-1" strike="noStrike">
                 <a:solidFill>
                   <a:schemeClr val="dk1">
@@ -4945,7 +4945,7 @@
         <p:spPr>
           <a:xfrm>
             <a:off x="838080" y="6356520"/>
-            <a:ext cx="2742480" cy="364320"/>
+            <a:ext cx="2742120" cy="363960"/>
           </a:xfrm>
           <a:prstGeom prst="rect">
             <a:avLst/>
@@ -5305,7 +5305,7 @@
         <p:spPr>
           <a:xfrm>
             <a:off x="0" y="204840"/>
-            <a:ext cx="10514880" cy="1324800"/>
+            <a:ext cx="10514520" cy="1324440"/>
           </a:xfrm>
           <a:prstGeom prst="rect">
             <a:avLst/>
@@ -5363,7 +5363,7 @@
         <p:spPr>
           <a:xfrm>
             <a:off x="838080" y="1825560"/>
-            <a:ext cx="10514880" cy="4350600"/>
+            <a:ext cx="10514520" cy="4350240"/>
           </a:xfrm>
           <a:prstGeom prst="rect">
             <a:avLst/>
@@ -5602,7 +5602,7 @@
         <p:spPr>
           <a:xfrm>
             <a:off x="0" y="0"/>
-            <a:ext cx="12191400" cy="6929640"/>
+            <a:ext cx="12191040" cy="6929280"/>
           </a:xfrm>
           <a:prstGeom prst="rect">
             <a:avLst/>
@@ -5911,7 +5911,7 @@
         <p:spPr>
           <a:xfrm>
             <a:off x="0" y="0"/>
-            <a:ext cx="12191400" cy="6857280"/>
+            <a:ext cx="12191040" cy="6856920"/>
           </a:xfrm>
           <a:prstGeom prst="rect">
             <a:avLst/>
@@ -6232,7 +6232,7 @@
         <p:spPr>
           <a:xfrm>
             <a:off x="273240" y="452520"/>
-            <a:ext cx="11079720" cy="5723640"/>
+            <a:ext cx="11079360" cy="5723280"/>
           </a:xfrm>
           <a:prstGeom prst="rect">
             <a:avLst/>
@@ -6360,7 +6360,7 @@
         <p:spPr>
           <a:xfrm>
             <a:off x="0" y="0"/>
-            <a:ext cx="12191400" cy="6857280"/>
+            <a:ext cx="12191040" cy="6856920"/>
           </a:xfrm>
           <a:prstGeom prst="rect">
             <a:avLst/>
@@ -6590,7 +6590,7 @@
         <p:spPr>
           <a:xfrm>
             <a:off x="603360" y="3497400"/>
-            <a:ext cx="10868400" cy="3185640"/>
+            <a:ext cx="10868040" cy="3185280"/>
           </a:xfrm>
           <a:prstGeom prst="rect">
             <a:avLst/>
@@ -6643,7 +6643,7 @@
         <p:spPr>
           <a:xfrm>
             <a:off x="0" y="0"/>
-            <a:ext cx="11352960" cy="6857280"/>
+            <a:ext cx="11352600" cy="6856920"/>
           </a:xfrm>
           <a:prstGeom prst="rect">
             <a:avLst/>
@@ -6728,16 +6728,7 @@
                 </a:solidFill>
                 <a:latin typeface="Calibri"/>
               </a:rPr>
-              <a:t> is responsible for </a:t>
-            </a:r>
-            <a:r>
-              <a:rPr b="0" lang="en-US" sz="2800" spc="-1" strike="noStrike">
-                <a:solidFill>
-                  <a:schemeClr val="dk1"/>
-                </a:solidFill>
-                <a:latin typeface="Calibri"/>
-              </a:rPr>
-              <a:t>communication between applications running on two different end systems. </a:t>
+              <a:t> is responsible for communication between applications running on two different end systems. </a:t>
             </a:r>
             <a:endParaRPr b="0" lang="en-US" sz="2800" spc="-1" strike="noStrike">
               <a:solidFill>
@@ -6770,25 +6761,7 @@
                 </a:solidFill>
                 <a:latin typeface="Calibri"/>
               </a:rPr>
-              <a:t>A message or data transferred from one end is readable for the </a:t>
-            </a:r>
-            <a:r>
-              <a:rPr b="0" lang="en-US" sz="2800" spc="-1" strike="noStrike">
-                <a:solidFill>
-                  <a:schemeClr val="dk1"/>
-                </a:solidFill>
-                <a:latin typeface="Calibri"/>
-              </a:rPr>
-              <a:t>corresponding application on the other end. These applications include web </a:t>
-            </a:r>
-            <a:r>
-              <a:rPr b="0" lang="en-US" sz="2800" spc="-1" strike="noStrike">
-                <a:solidFill>
-                  <a:schemeClr val="dk1"/>
-                </a:solidFill>
-                <a:latin typeface="Calibri"/>
-              </a:rPr>
-              <a:t>browsers, email clients, etc.</a:t>
+              <a:t>A message or data transferred from one end is readable for the corresponding application on the other end. These applications include web browsers, email clients, etc.</a:t>
             </a:r>
             <a:endParaRPr b="0" lang="en-US" sz="2800" spc="-1" strike="noStrike">
               <a:solidFill>
@@ -7004,16 +6977,7 @@
                 </a:solidFill>
                 <a:latin typeface="Calibri"/>
               </a:rPr>
-              <a:t>Domain Name System (DNS): for translation of human-friendly domain </a:t>
-            </a:r>
-            <a:r>
-              <a:rPr b="0" lang="en-US" sz="2800" spc="-1" strike="noStrike">
-                <a:solidFill>
-                  <a:schemeClr val="dk1"/>
-                </a:solidFill>
-                <a:latin typeface="Calibri"/>
-              </a:rPr>
-              <a:t>names into IP addresses</a:t>
+              <a:t>Domain Name System (DNS): for translation of human-friendly domain names into IP addresses</a:t>
             </a:r>
             <a:endParaRPr b="0" lang="en-US" sz="2800" spc="-1" strike="noStrike">
               <a:solidFill>
@@ -7087,7 +7051,7 @@
         <p:spPr>
           <a:xfrm>
             <a:off x="0" y="0"/>
-            <a:ext cx="12309840" cy="6756120"/>
+            <a:ext cx="12309480" cy="6755760"/>
           </a:xfrm>
           <a:prstGeom prst="rect">
             <a:avLst/>
@@ -7426,7 +7390,7 @@
         <p:spPr>
           <a:xfrm>
             <a:off x="0" y="95400"/>
-            <a:ext cx="12191400" cy="6761880"/>
+            <a:ext cx="12191040" cy="6761520"/>
           </a:xfrm>
           <a:prstGeom prst="rect">
             <a:avLst/>
@@ -7735,7 +7699,7 @@
         <p:spPr>
           <a:xfrm>
             <a:off x="0" y="0"/>
-            <a:ext cx="12191400" cy="6857280"/>
+            <a:ext cx="12191040" cy="6856920"/>
           </a:xfrm>
           <a:prstGeom prst="rect">
             <a:avLst/>
@@ -8094,7 +8058,7 @@
         <p:spPr>
           <a:xfrm>
             <a:off x="-67320" y="0"/>
-            <a:ext cx="12258720" cy="6857280"/>
+            <a:ext cx="12258360" cy="6856920"/>
           </a:xfrm>
           <a:prstGeom prst="rect">
             <a:avLst/>
@@ -8442,7 +8406,7 @@
         <p:spPr>
           <a:xfrm>
             <a:off x="0" y="0"/>
-            <a:ext cx="12191400" cy="6857280"/>
+            <a:ext cx="12191040" cy="6856920"/>
           </a:xfrm>
           <a:prstGeom prst="rect">
             <a:avLst/>
@@ -8710,7 +8674,7 @@
         <p:spPr>
           <a:xfrm>
             <a:off x="84960" y="763560"/>
-            <a:ext cx="11735640" cy="5919480"/>
+            <a:ext cx="11735280" cy="5919120"/>
           </a:xfrm>
           <a:prstGeom prst="rect">
             <a:avLst/>
@@ -8858,7 +8822,7 @@
         <p:spPr>
           <a:xfrm>
             <a:off x="0" y="0"/>
-            <a:ext cx="12191400" cy="6857280"/>
+            <a:ext cx="12191040" cy="6856920"/>
           </a:xfrm>
           <a:prstGeom prst="rect">
             <a:avLst/>
@@ -9159,7 +9123,7 @@
         <p:spPr>
           <a:xfrm>
             <a:off x="0" y="0"/>
-            <a:ext cx="12191400" cy="6857280"/>
+            <a:ext cx="12191040" cy="6856920"/>
           </a:xfrm>
           <a:prstGeom prst="rect">
             <a:avLst/>
@@ -9454,7 +9418,7 @@
         <p:spPr>
           <a:xfrm>
             <a:off x="0" y="0"/>
-            <a:ext cx="12191400" cy="6857280"/>
+            <a:ext cx="12191040" cy="6856920"/>
           </a:xfrm>
           <a:prstGeom prst="rect">
             <a:avLst/>
@@ -9935,7 +9899,7 @@
         <p:spPr>
           <a:xfrm>
             <a:off x="0" y="0"/>
-            <a:ext cx="12191400" cy="6857280"/>
+            <a:ext cx="12191040" cy="6856920"/>
           </a:xfrm>
           <a:prstGeom prst="rect">
             <a:avLst/>
@@ -10253,7 +10217,7 @@
         <p:spPr>
           <a:xfrm>
             <a:off x="0" y="0"/>
-            <a:ext cx="12191400" cy="6857280"/>
+            <a:ext cx="12191040" cy="6856920"/>
           </a:xfrm>
           <a:prstGeom prst="rect">
             <a:avLst/>
@@ -10661,7 +10625,7 @@
         <p:spPr>
           <a:xfrm>
             <a:off x="0" y="0"/>
-            <a:ext cx="11886480" cy="6701760"/>
+            <a:ext cx="11886120" cy="6701400"/>
           </a:xfrm>
           <a:prstGeom prst="rect">
             <a:avLst/>
@@ -10869,7 +10833,7 @@
         <p:spPr>
           <a:xfrm>
             <a:off x="0" y="0"/>
-            <a:ext cx="6019200" cy="6857280"/>
+            <a:ext cx="6018840" cy="6856920"/>
           </a:xfrm>
           <a:prstGeom prst="rect">
             <a:avLst/>
@@ -11052,7 +11016,7 @@
         <p:spPr>
           <a:xfrm>
             <a:off x="6934320" y="993960"/>
-            <a:ext cx="4694040" cy="4731480"/>
+            <a:ext cx="4693680" cy="4731120"/>
           </a:xfrm>
           <a:prstGeom prst="rect">
             <a:avLst/>
@@ -11105,7 +11069,7 @@
         <p:spPr>
           <a:xfrm>
             <a:off x="0" y="0"/>
-            <a:ext cx="12191400" cy="6857280"/>
+            <a:ext cx="12191040" cy="6856920"/>
           </a:xfrm>
           <a:prstGeom prst="rect">
             <a:avLst/>
@@ -11408,7 +11372,7 @@
         <p:spPr>
           <a:xfrm>
             <a:off x="0" y="0"/>
-            <a:ext cx="12191400" cy="6857280"/>
+            <a:ext cx="12191040" cy="6856920"/>
           </a:xfrm>
           <a:prstGeom prst="rect">
             <a:avLst/>
@@ -11634,7 +11598,7 @@
         <p:spPr>
           <a:xfrm>
             <a:off x="0" y="0"/>
-            <a:ext cx="12191400" cy="6720480"/>
+            <a:ext cx="12191040" cy="6720120"/>
           </a:xfrm>
           <a:prstGeom prst="rect">
             <a:avLst/>
@@ -11916,7 +11880,7 @@
         <p:spPr>
           <a:xfrm>
             <a:off x="0" y="0"/>
-            <a:ext cx="12191400" cy="1053000"/>
+            <a:ext cx="12191040" cy="1052640"/>
           </a:xfrm>
           <a:prstGeom prst="rect">
             <a:avLst/>
@@ -11971,7 +11935,7 @@
         <p:spPr>
           <a:xfrm>
             <a:off x="0" y="1441080"/>
-            <a:ext cx="12191400" cy="5416200"/>
+            <a:ext cx="12191040" cy="5415840"/>
           </a:xfrm>
           <a:prstGeom prst="rect">
             <a:avLst/>
@@ -12122,7 +12086,7 @@
         <p:spPr>
           <a:xfrm>
             <a:off x="0" y="0"/>
-            <a:ext cx="12115080" cy="6857280"/>
+            <a:ext cx="12114720" cy="6856920"/>
           </a:xfrm>
           <a:prstGeom prst="rect">
             <a:avLst/>
@@ -12545,7 +12509,7 @@
         <p:spPr>
           <a:xfrm>
             <a:off x="0" y="0"/>
-            <a:ext cx="12191400" cy="6857280"/>
+            <a:ext cx="12191040" cy="6856920"/>
           </a:xfrm>
           <a:prstGeom prst="rect">
             <a:avLst/>
@@ -12821,7 +12785,7 @@
         <p:spPr>
           <a:xfrm>
             <a:off x="292320" y="716400"/>
-            <a:ext cx="11061000" cy="5909760"/>
+            <a:ext cx="11060640" cy="5909400"/>
           </a:xfrm>
           <a:prstGeom prst="rect">
             <a:avLst/>
@@ -12989,7 +12953,7 @@
         <p:spPr>
           <a:xfrm>
             <a:off x="0" y="0"/>
-            <a:ext cx="6896880" cy="6857280"/>
+            <a:ext cx="6896520" cy="6856920"/>
           </a:xfrm>
           <a:prstGeom prst="rect">
             <a:avLst/>
@@ -13311,7 +13275,7 @@
         <p:spPr>
           <a:xfrm>
             <a:off x="7086600" y="218520"/>
-            <a:ext cx="5104800" cy="6549120"/>
+            <a:ext cx="5104440" cy="6548760"/>
           </a:xfrm>
           <a:prstGeom prst="rect">
             <a:avLst/>
@@ -13364,7 +13328,7 @@
         <p:spPr>
           <a:xfrm>
             <a:off x="0" y="0"/>
-            <a:ext cx="12191400" cy="575640"/>
+            <a:ext cx="12191040" cy="575280"/>
           </a:xfrm>
           <a:prstGeom prst="rect">
             <a:avLst/>
@@ -13425,7 +13389,7 @@
         <p:spPr>
           <a:xfrm>
             <a:off x="0" y="725400"/>
-            <a:ext cx="12115080" cy="6131880"/>
+            <a:ext cx="12114720" cy="6131520"/>
           </a:xfrm>
           <a:prstGeom prst="rect">
             <a:avLst/>
@@ -13782,7 +13746,7 @@
         <p:spPr>
           <a:xfrm>
             <a:off x="0" y="0"/>
-            <a:ext cx="7582680" cy="6857280"/>
+            <a:ext cx="7582320" cy="6856920"/>
           </a:xfrm>
           <a:prstGeom prst="rect">
             <a:avLst/>
@@ -14038,7 +14002,7 @@
         <p:spPr>
           <a:xfrm>
             <a:off x="7822080" y="1073520"/>
-            <a:ext cx="3945240" cy="5237280"/>
+            <a:ext cx="3944880" cy="5236920"/>
           </a:xfrm>
           <a:prstGeom prst="rect">
             <a:avLst/>
@@ -14091,7 +14055,7 @@
         <p:spPr>
           <a:xfrm>
             <a:off x="0" y="0"/>
-            <a:ext cx="12191400" cy="6857280"/>
+            <a:ext cx="12191040" cy="6856920"/>
           </a:xfrm>
           <a:prstGeom prst="rect">
             <a:avLst/>
@@ -14484,7 +14448,7 @@
         <p:spPr>
           <a:xfrm>
             <a:off x="0" y="0"/>
-            <a:ext cx="12191400" cy="6857280"/>
+            <a:ext cx="12191040" cy="6856920"/>
           </a:xfrm>
           <a:prstGeom prst="rect">
             <a:avLst/>
@@ -14802,7 +14766,7 @@
         <p:spPr>
           <a:xfrm>
             <a:off x="0" y="0"/>
-            <a:ext cx="12095280" cy="6857280"/>
+            <a:ext cx="12094920" cy="6856920"/>
           </a:xfrm>
           <a:prstGeom prst="rect">
             <a:avLst/>
@@ -15239,7 +15203,7 @@
         <p:spPr>
           <a:xfrm>
             <a:off x="79560" y="0"/>
-            <a:ext cx="7413840" cy="6857280"/>
+            <a:ext cx="7413480" cy="6856920"/>
           </a:xfrm>
           <a:prstGeom prst="rect">
             <a:avLst/>
@@ -15523,7 +15487,7 @@
         <p:spPr>
           <a:xfrm>
             <a:off x="7643160" y="566640"/>
-            <a:ext cx="4329000" cy="5480640"/>
+            <a:ext cx="4328640" cy="5480280"/>
           </a:xfrm>
           <a:prstGeom prst="rect">
             <a:avLst/>
@@ -15576,7 +15540,7 @@
         <p:spPr>
           <a:xfrm>
             <a:off x="0" y="0"/>
-            <a:ext cx="12191400" cy="585720"/>
+            <a:ext cx="12191040" cy="585360"/>
           </a:xfrm>
           <a:prstGeom prst="rect">
             <a:avLst/>
@@ -15637,7 +15601,7 @@
         <p:spPr>
           <a:xfrm>
             <a:off x="0" y="884520"/>
-            <a:ext cx="12191400" cy="5972760"/>
+            <a:ext cx="12191040" cy="5972400"/>
           </a:xfrm>
           <a:prstGeom prst="rect">
             <a:avLst/>
@@ -15896,7 +15860,7 @@
         <p:spPr>
           <a:xfrm>
             <a:off x="0" y="0"/>
-            <a:ext cx="12191400" cy="933480"/>
+            <a:ext cx="12191040" cy="933120"/>
           </a:xfrm>
           <a:prstGeom prst="rect">
             <a:avLst/>
@@ -15957,7 +15921,7 @@
         <p:spPr>
           <a:xfrm>
             <a:off x="0" y="1033560"/>
-            <a:ext cx="12065400" cy="5694480"/>
+            <a:ext cx="12065040" cy="5694120"/>
           </a:xfrm>
           <a:prstGeom prst="rect">
             <a:avLst/>
@@ -16234,7 +16198,7 @@
         <p:spPr>
           <a:xfrm>
             <a:off x="0" y="0"/>
-            <a:ext cx="12191400" cy="6857280"/>
+            <a:ext cx="12191040" cy="6856920"/>
           </a:xfrm>
           <a:prstGeom prst="rect">
             <a:avLst/>
@@ -16937,7 +16901,7 @@
         <p:spPr>
           <a:xfrm>
             <a:off x="838080" y="542880"/>
-            <a:ext cx="10524240" cy="6162120"/>
+            <a:ext cx="10523880" cy="6161760"/>
           </a:xfrm>
           <a:prstGeom prst="rect">
             <a:avLst/>
@@ -16989,8 +16953,8 @@
         </p:blipFill>
         <p:spPr>
           <a:xfrm>
-            <a:off x="866880" y="976680"/>
-            <a:ext cx="10010160" cy="5652360"/>
+            <a:off x="963000" y="914400"/>
+            <a:ext cx="10009800" cy="5652000"/>
           </a:xfrm>
           <a:prstGeom prst="rect">
             <a:avLst/>
@@ -17009,7 +16973,7 @@
         <p:spPr>
           <a:xfrm>
             <a:off x="6400800" y="3657600"/>
-            <a:ext cx="1142640" cy="456840"/>
+            <a:ext cx="1142280" cy="456480"/>
           </a:xfrm>
           <a:prstGeom prst="rect">
             <a:avLst/>
@@ -17041,6 +17005,7 @@
                   <a:srgbClr val="000000"/>
                 </a:solidFill>
                 <a:latin typeface="Arial"/>
+                <a:ea typeface="DejaVu Sans"/>
               </a:rPr>
               <a:t>packet</a:t>
             </a:r>
@@ -17062,7 +17027,7 @@
         <p:spPr>
           <a:xfrm>
             <a:off x="6172200" y="4343400"/>
-            <a:ext cx="1142640" cy="456840"/>
+            <a:ext cx="1142280" cy="456480"/>
           </a:xfrm>
           <a:prstGeom prst="rect">
             <a:avLst/>
@@ -17094,6 +17059,7 @@
                   <a:srgbClr val="000000"/>
                 </a:solidFill>
                 <a:latin typeface="Arial"/>
+                <a:ea typeface="DejaVu Sans"/>
               </a:rPr>
               <a:t>message</a:t>
             </a:r>
@@ -17115,7 +17081,7 @@
         <p:spPr>
           <a:xfrm>
             <a:off x="6172200" y="5257800"/>
-            <a:ext cx="1142640" cy="456840"/>
+            <a:ext cx="1142280" cy="456480"/>
           </a:xfrm>
           <a:prstGeom prst="rect">
             <a:avLst/>
@@ -17147,6 +17113,7 @@
                   <a:srgbClr val="000000"/>
                 </a:solidFill>
                 <a:latin typeface="Arial"/>
+                <a:ea typeface="DejaVu Sans"/>
               </a:rPr>
               <a:t>frame</a:t>
             </a:r>
@@ -17168,7 +17135,7 @@
         <p:spPr>
           <a:xfrm>
             <a:off x="6172200" y="5943600"/>
-            <a:ext cx="1142640" cy="456840"/>
+            <a:ext cx="1142280" cy="456480"/>
           </a:xfrm>
           <a:prstGeom prst="rect">
             <a:avLst/>
@@ -17200,6 +17167,7 @@
                   <a:srgbClr val="000000"/>
                 </a:solidFill>
                 <a:latin typeface="Arial"/>
+                <a:ea typeface="DejaVu Sans"/>
               </a:rPr>
               <a:t>bit</a:t>
             </a:r>

</xml_diff>